<commit_message>
lesson: compare naive RAG with context baselines
</commit_message>
<xml_diff>
--- a/decks/04-rag-from-scratch.pptx
+++ b/decks/04-rag-from-scratch.pptx
@@ -2,19 +2,19 @@
 <file path=ppt/presentation.xml><?xml version="1.0" encoding="utf-8"?>
 <p:presentation xmlns:p="http://schemas.openxmlformats.org/presentationml/2006/main">
   <p:sldMasterIdLst>
-    <p:sldMasterId xmlns:r="http://schemas.openxmlformats.org/officeDocument/2006/relationships" id="2147483648" r:id="R648988c15d6e4d4a"/>
+    <p:sldMasterId xmlns:r="http://schemas.openxmlformats.org/officeDocument/2006/relationships" id="2147483648" r:id="R93bd745b18e141fd"/>
   </p:sldMasterIdLst>
   <p:notesMasterIdLst>
-    <p:notesMasterId xmlns:r="http://schemas.openxmlformats.org/officeDocument/2006/relationships" r:id="R4138b46469354d2f"/>
+    <p:notesMasterId xmlns:r="http://schemas.openxmlformats.org/officeDocument/2006/relationships" r:id="R791cbe43d5a4486c"/>
   </p:notesMasterIdLst>
   <p:sldIdLst>
-    <p:sldId xmlns:r="http://schemas.openxmlformats.org/officeDocument/2006/relationships" id="256" r:id="Rfc04dd10f4614fd6"/>
-    <p:sldId xmlns:r="http://schemas.openxmlformats.org/officeDocument/2006/relationships" id="257" r:id="R82bfb632c2184cca"/>
-    <p:sldId xmlns:r="http://schemas.openxmlformats.org/officeDocument/2006/relationships" id="258" r:id="R039921ee26624137"/>
-    <p:sldId xmlns:r="http://schemas.openxmlformats.org/officeDocument/2006/relationships" id="259" r:id="R0715dc261b7b4320"/>
-    <p:sldId xmlns:r="http://schemas.openxmlformats.org/officeDocument/2006/relationships" id="260" r:id="R19859cf3caaa45fa"/>
-    <p:sldId xmlns:r="http://schemas.openxmlformats.org/officeDocument/2006/relationships" id="261" r:id="Rb791b4243fd5467a"/>
-    <p:sldId xmlns:r="http://schemas.openxmlformats.org/officeDocument/2006/relationships" id="262" r:id="Ref313dae6a024b63"/>
+    <p:sldId xmlns:r="http://schemas.openxmlformats.org/officeDocument/2006/relationships" id="256" r:id="R71a77bda6f26463c"/>
+    <p:sldId xmlns:r="http://schemas.openxmlformats.org/officeDocument/2006/relationships" id="257" r:id="R7b9ba3a1e896475e"/>
+    <p:sldId xmlns:r="http://schemas.openxmlformats.org/officeDocument/2006/relationships" id="258" r:id="R423ac0eff0c446c9"/>
+    <p:sldId xmlns:r="http://schemas.openxmlformats.org/officeDocument/2006/relationships" id="259" r:id="R57456d22027e4904"/>
+    <p:sldId xmlns:r="http://schemas.openxmlformats.org/officeDocument/2006/relationships" id="260" r:id="R2043c06fdcb04632"/>
+    <p:sldId xmlns:r="http://schemas.openxmlformats.org/officeDocument/2006/relationships" id="261" r:id="R4231f044fee54a69"/>
+    <p:sldId xmlns:r="http://schemas.openxmlformats.org/officeDocument/2006/relationships" id="262" r:id="R306eb48e93c247e6"/>
   </p:sldIdLst>
   <p:sldSz cx="15240000" cy="8572500"/>
   <p:notesSz cx="6858000" cy="9144000"/>
@@ -448,12 +448,7 @@
           <a:lstStyle xmlns:a="http://schemas.openxmlformats.org/drawingml/2006/main"/>
           <a:p xmlns:a="http://schemas.openxmlformats.org/drawingml/2006/main">
             <a:r>
-              <a:t>Open by calling this a naive baseline: it is intentionally simple and fully observable.</a:t>
-            </a:r>
-          </a:p>
-          <a:p xmlns:a="http://schemas.openxmlformats.org/drawingml/2006/main">
-            <a:r>
-              <a:t>The lesson builds the retrieval mechanism; parsing and chunking come next.</a:t>
+              <a:t>Introduce a transparent RAG baseline before raw-document complexity. Every decision remains visible.</a:t>
             </a:r>
           </a:p>
           <a:p xmlns:a="http://schemas.openxmlformats.org/drawingml/2006/main">
@@ -468,7 +463,17 @@
           </a:p>
           <a:p xmlns:a="http://schemas.openxmlformats.org/drawingml/2006/main">
             <a:r>
-              <a:t>- Course-owned diagram and copy.</a:t>
+              <a:t>- https://arxiv.org/abs/2005.11401</a:t>
+            </a:r>
+          </a:p>
+          <a:p xmlns:a="http://schemas.openxmlformats.org/drawingml/2006/main">
+            <a:r>
+              <a:t>- https://www.sec.gov/Archives/edgar/data/1045810/000104581026000021/nvda-20260125.htm</a:t>
+            </a:r>
+          </a:p>
+          <a:p xmlns:a="http://schemas.openxmlformats.org/drawingml/2006/main">
+            <a:r>
+              <a:t>- https://www.se.com/ww/en/assets/564/document/528237/release-fy-results-2025.pdf?p_File_Name=2025+FY+Results&amp;p_enDocType=Financial+release</a:t>
             </a:r>
           </a:p>
           <a:p xmlns:a="http://schemas.openxmlformats.org/drawingml/2006/main">
@@ -543,12 +548,7 @@
           <a:lstStyle xmlns:a="http://schemas.openxmlformats.org/drawingml/2006/main"/>
           <a:p xmlns:a="http://schemas.openxmlformats.org/drawingml/2006/main">
             <a:r>
-              <a:t>Point to the six source passages, then the two selected passages.</a:t>
-            </a:r>
-          </a:p>
-          <a:p xmlns:a="http://schemas.openxmlformats.org/drawingml/2006/main">
-            <a:r>
-              <a:t>Emphasize that retrieval is application code executed before the model call.</a:t>
+              <a:t>The application, not the model, selects evidence. Only the top-k passages enter the generation prompt.</a:t>
             </a:r>
           </a:p>
           <a:p xmlns:a="http://schemas.openxmlformats.org/drawingml/2006/main">
@@ -563,7 +563,17 @@
           </a:p>
           <a:p xmlns:a="http://schemas.openxmlformats.org/drawingml/2006/main">
             <a:r>
-              <a:t>- Course-owned diagram and copy.</a:t>
+              <a:t>- https://arxiv.org/abs/2005.11401</a:t>
+            </a:r>
+          </a:p>
+          <a:p xmlns:a="http://schemas.openxmlformats.org/drawingml/2006/main">
+            <a:r>
+              <a:t>- https://scikit-learn.org/stable/modules/generated/sklearn.feature_extraction.text.TfidfVectorizer.html</a:t>
+            </a:r>
+          </a:p>
+          <a:p xmlns:a="http://schemas.openxmlformats.org/drawingml/2006/main">
+            <a:r>
+              <a:t>- https://scikit-learn.org/stable/modules/generated/sklearn.metrics.pairwise.cosine_similarity.html</a:t>
             </a:r>
           </a:p>
           <a:p xmlns:a="http://schemas.openxmlformats.org/drawingml/2006/main">
@@ -638,12 +648,7 @@
           <a:lstStyle xmlns:a="http://schemas.openxmlformats.org/drawingml/2006/main"/>
           <a:p xmlns:a="http://schemas.openxmlformats.org/drawingml/2006/main">
             <a:r>
-              <a:t>Reveal the pipeline from left to right.</a:t>
-            </a:r>
-          </a:p>
-          <a:p xmlns:a="http://schemas.openxmlformats.org/drawingml/2006/main">
-            <a:r>
-              <a:t>Ask which stages can be tested without OpenAI or Ollama; the answer is stages one through four.</a:t>
+              <a:t>Hold the question fixed. No context exposes missing evidence; full context exposes all six passages; naive RAG uses a blank-line split, lexical rank and top-k selection.</a:t>
             </a:r>
           </a:p>
           <a:p xmlns:a="http://schemas.openxmlformats.org/drawingml/2006/main">
@@ -658,7 +663,12 @@
           </a:p>
           <a:p xmlns:a="http://schemas.openxmlformats.org/drawingml/2006/main">
             <a:r>
-              <a:t>- Course-owned diagram and copy.</a:t>
+              <a:t>- https://arxiv.org/abs/2005.11401</a:t>
+            </a:r>
+          </a:p>
+          <a:p xmlns:a="http://schemas.openxmlformats.org/drawingml/2006/main">
+            <a:r>
+              <a:t>- https://scikit-learn.org/stable/modules/generated/sklearn.feature_extraction.text.TfidfVectorizer.html</a:t>
             </a:r>
           </a:p>
           <a:p xmlns:a="http://schemas.openxmlformats.org/drawingml/2006/main">
@@ -733,12 +743,7 @@
           <a:lstStyle xmlns:a="http://schemas.openxmlformats.org/drawingml/2006/main"/>
           <a:p xmlns:a="http://schemas.openxmlformats.org/drawingml/2006/main">
             <a:r>
-              <a:t>The matrix is a compact teaching view of selected terms; the notebook exposes the live matrix.</a:t>
-            </a:r>
-          </a:p>
-          <a:p xmlns:a="http://schemas.openxmlformats.org/drawingml/2006/main">
-            <a:r>
-              <a:t>The ranking values shown here are generated by Notebook 04 for the maintained question.</a:t>
+              <a:t>Read the teaching heatmap and cosine rank together. Similarity is a lexical signal, not probability or financial confidence.</a:t>
             </a:r>
           </a:p>
           <a:p xmlns:a="http://schemas.openxmlformats.org/drawingml/2006/main">
@@ -833,17 +838,7 @@
           <a:lstStyle xmlns:a="http://schemas.openxmlformats.org/drawingml/2006/main"/>
           <a:p xmlns:a="http://schemas.openxmlformats.org/drawingml/2006/main">
             <a:r>
-              <a:t>Use the orange line as the decision boundary.</a:t>
-            </a:r>
-          </a:p>
-          <a:p xmlns:a="http://schemas.openxmlformats.org/drawingml/2006/main">
-            <a:r>
-              <a:t>For the maintained question, the expected evidence set is NVDA-F1 and NVDA-F2.</a:t>
-            </a:r>
-          </a:p>
-          <a:p xmlns:a="http://schemas.openxmlformats.org/drawingml/2006/main">
-            <a:r>
-              <a:t>Changing top-k changes both recall and context noise.</a:t>
+              <a:t>Top-k trades evidence coverage against noise, token use and cross-company leakage. Keep stable IDs and URLs in selected context.</a:t>
             </a:r>
           </a:p>
           <a:p xmlns:a="http://schemas.openxmlformats.org/drawingml/2006/main">
@@ -854,6 +849,11 @@
           <a:p xmlns:a="http://schemas.openxmlformats.org/drawingml/2006/main">
             <a:r>
               <a:t>[Sources]</a:t>
+            </a:r>
+          </a:p>
+          <a:p xmlns:a="http://schemas.openxmlformats.org/drawingml/2006/main">
+            <a:r>
+              <a:t>- https://arxiv.org/abs/2005.11401</a:t>
             </a:r>
           </a:p>
           <a:p xmlns:a="http://schemas.openxmlformats.org/drawingml/2006/main">
@@ -938,17 +938,7 @@
           <a:lstStyle xmlns:a="http://schemas.openxmlformats.org/drawingml/2006/main"/>
           <a:p xmlns:a="http://schemas.openxmlformats.org/drawingml/2006/main">
             <a:r>
-              <a:t>Run Notebook 04 after this slide.</a:t>
-            </a:r>
-          </a:p>
-          <a:p xmlns:a="http://schemas.openxmlformats.org/drawingml/2006/main">
-            <a:r>
-              <a:t>The notebook produces six figures and checks retrieval separately from grounding.</a:t>
-            </a:r>
-          </a:p>
-          <a:p xmlns:a="http://schemas.openxmlformats.org/drawingml/2006/main">
-            <a:r>
-              <a:t>The failure query has zero lexical scores and returns NVDA-F1 through the stable identifier tie-break, while the intended evidence is NVDA-F2.</a:t>
+              <a:t>Separate retrieval recall from answer grounding. The semantic failure occurs before any model call.</a:t>
             </a:r>
           </a:p>
           <a:p xmlns:a="http://schemas.openxmlformats.org/drawingml/2006/main">
@@ -963,7 +953,12 @@
           </a:p>
           <a:p xmlns:a="http://schemas.openxmlformats.org/drawingml/2006/main">
             <a:r>
-              <a:t>- Course-owned diagram and copy.</a:t>
+              <a:t>- https://scikit-learn.org/stable/modules/generated/sklearn.feature_extraction.text.TfidfVectorizer.html</a:t>
+            </a:r>
+          </a:p>
+          <a:p xmlns:a="http://schemas.openxmlformats.org/drawingml/2006/main">
+            <a:r>
+              <a:t>- https://scikit-learn.org/stable/modules/generated/sklearn.metrics.pairwise.cosine_similarity.html</a:t>
             </a:r>
           </a:p>
           <a:p xmlns:a="http://schemas.openxmlformats.org/drawingml/2006/main">
@@ -1038,17 +1033,7 @@
           <a:lstStyle xmlns:a="http://schemas.openxmlformats.org/drawingml/2006/main"/>
           <a:p xmlns:a="http://schemas.openxmlformats.org/drawingml/2006/main">
             <a:r>
-              <a:t>Close by asking who created the prepared passages and what may have been lost.</a:t>
-            </a:r>
-          </a:p>
-          <a:p xmlns:a="http://schemas.openxmlformats.org/drawingml/2006/main">
-            <a:r>
-              <a:t>That question opens Lesson 05: raw financial documents, parsing, structure, tables, metadata and chunking.</a:t>
-            </a:r>
-          </a:p>
-          <a:p xmlns:a="http://schemas.openxmlformats.org/drawingml/2006/main">
-            <a:r>
-              <a:t>Lesson 06 then improves retrieval representation and ranking.</a:t>
+              <a:t>End with the raw-document question: prepared passages and blank-line boundaries hide parsing, tables, hierarchy and semantic choices taught in Lesson 05.</a:t>
             </a:r>
           </a:p>
           <a:p xmlns:a="http://schemas.openxmlformats.org/drawingml/2006/main">
@@ -1063,7 +1048,12 @@
           </a:p>
           <a:p xmlns:a="http://schemas.openxmlformats.org/drawingml/2006/main">
             <a:r>
-              <a:t>- Course-owned diagram and copy.</a:t>
+              <a:t>- https://www.sec.gov/Archives/edgar/data/1045810/000104581026000021/nvda-20260125.htm</a:t>
+            </a:r>
+          </a:p>
+          <a:p xmlns:a="http://schemas.openxmlformats.org/drawingml/2006/main">
+            <a:r>
+              <a:t>- https://www.se.com/ww/en/assets/564/document/528237/release-fy-results-2025.pdf?p_File_Name=2025+FY+Results&amp;p_enDocType=Financial+release</a:t>
             </a:r>
           </a:p>
           <a:p xmlns:a="http://schemas.openxmlformats.org/drawingml/2006/main">
@@ -1136,7 +1126,7 @@
   </p:cSld>
   <p:clrMap bg1="lt1" tx1="dk1" bg2="lt2" tx2="dk2" accent1="accent1" accent2="accent2" accent3="accent3" accent4="accent4" accent5="accent5" accent6="accent6" hlink="hlink" folHlink="folHlink"/>
   <p:sldLayoutIdLst>
-    <p:sldLayoutId xmlns:r="http://schemas.openxmlformats.org/officeDocument/2006/relationships" id="2147483649" r:id="R0b24e43ffc7940bc"/>
+    <p:sldLayoutId xmlns:r="http://schemas.openxmlformats.org/officeDocument/2006/relationships" id="2147483649" r:id="R6ea81dd6c41843b8"/>
   </p:sldLayoutIdLst>
   <p:txStyles>
     <p:titleStyle>
@@ -3522,7 +3512,7 @@
       </p:sp>
       <p:cxnSp>
         <p:nvCxnSpPr>
-          <p:cNvPr id="66" name=""/>
+          <p:cNvPr id="128" name=""/>
           <p:cNvCxnSpPr>
             <a:stCxn xmlns:a="http://schemas.openxmlformats.org/drawingml/2006/main" id="3" idx="3"/>
             <a:endCxn xmlns:a="http://schemas.openxmlformats.org/drawingml/2006/main" id="17" idx="1"/>
@@ -3548,7 +3538,7 @@
       </p:cxnSp>
       <p:cxnSp>
         <p:nvCxnSpPr>
-          <p:cNvPr id="67" name=""/>
+          <p:cNvPr id="129" name=""/>
           <p:cNvCxnSpPr>
             <a:stCxn xmlns:a="http://schemas.openxmlformats.org/drawingml/2006/main" id="17" idx="3"/>
             <a:endCxn xmlns:a="http://schemas.openxmlformats.org/drawingml/2006/main" id="20" idx="1"/>
@@ -3574,7 +3564,7 @@
       </p:cxnSp>
       <p:cxnSp>
         <p:nvCxnSpPr>
-          <p:cNvPr id="68" name=""/>
+          <p:cNvPr id="130" name=""/>
           <p:cNvCxnSpPr>
             <a:stCxn xmlns:a="http://schemas.openxmlformats.org/drawingml/2006/main" id="20" idx="3"/>
             <a:endCxn xmlns:a="http://schemas.openxmlformats.org/drawingml/2006/main" id="26" idx="1"/>
@@ -3998,7 +3988,7 @@
                 <a:ea typeface="Calibri"/>
                 <a:cs typeface="Calibri"/>
               </a:rPr>
-              <a:t>NAIVE ARCHITECTURE</a:t>
+              <a:t>CONTEXT PATHS</a:t>
             </a:r>
           </a:p>
         </p:txBody>
@@ -4060,7 +4050,7 @@
                 <a:ea typeface="Calibri"/>
                 <a:cs typeface="Calibri"/>
               </a:rPr>
-              <a:t>The baseline has five observable stages</a:t>
+              <a:t>Same question, three evidence paths</a:t>
             </a:r>
           </a:p>
         </p:txBody>
@@ -4219,7 +4209,7 @@
                 <a:ea typeface="Calibri"/>
                 <a:cs typeface="Calibri"/>
               </a:rPr>
-              <a:t>Prepared</a:t>
+              <a:t>No</a:t>
             </a:r>
           </a:p>
           <a:p xmlns:a="http://schemas.openxmlformats.org/drawingml/2006/main">
@@ -4246,7 +4236,7 @@
                 <a:ea typeface="Calibri"/>
                 <a:cs typeface="Calibri"/>
               </a:rPr>
-              <a:t>passages</a:t>
+              <a:t>context</a:t>
             </a:r>
           </a:p>
         </p:txBody>
@@ -4308,7 +4298,7 @@
                 <a:ea typeface="Calibri"/>
                 <a:cs typeface="Calibri"/>
               </a:rPr>
-              <a:t>SOURCE</a:t>
+              <a:t>ZERO</a:t>
             </a:r>
           </a:p>
         </p:txBody>
@@ -4467,7 +4457,7 @@
                 <a:ea typeface="Calibri"/>
                 <a:cs typeface="Calibri"/>
               </a:rPr>
-              <a:t>TF-IDF</a:t>
+              <a:t>Full</a:t>
             </a:r>
           </a:p>
           <a:p xmlns:a="http://schemas.openxmlformats.org/drawingml/2006/main">
@@ -4494,7 +4484,7 @@
                 <a:ea typeface="Calibri"/>
                 <a:cs typeface="Calibri"/>
               </a:rPr>
-              <a:t>index</a:t>
+              <a:t>context</a:t>
             </a:r>
           </a:p>
         </p:txBody>
@@ -4556,7 +4546,7 @@
                 <a:ea typeface="Calibri"/>
                 <a:cs typeface="Calibri"/>
               </a:rPr>
-              <a:t>REPRESENT</a:t>
+              <a:t>ALL SIX</a:t>
             </a:r>
           </a:p>
         </p:txBody>
@@ -4715,7 +4705,7 @@
                 <a:ea typeface="Calibri"/>
                 <a:cs typeface="Calibri"/>
               </a:rPr>
-              <a:t>Cosine</a:t>
+              <a:t>Paragraph</a:t>
             </a:r>
           </a:p>
           <a:p xmlns:a="http://schemas.openxmlformats.org/drawingml/2006/main">
@@ -4742,7 +4732,7 @@
                 <a:ea typeface="Calibri"/>
                 <a:cs typeface="Calibri"/>
               </a:rPr>
-              <a:t>ranking</a:t>
+              <a:t>split</a:t>
             </a:r>
           </a:p>
         </p:txBody>
@@ -4804,7 +4794,7 @@
                 <a:ea typeface="Calibri"/>
                 <a:cs typeface="Calibri"/>
               </a:rPr>
-              <a:t>RANK</a:t>
+              <a:t>NAIVE</a:t>
             </a:r>
           </a:p>
         </p:txBody>
@@ -4963,34 +4953,34 @@
                 <a:ea typeface="Calibri"/>
                 <a:cs typeface="Calibri"/>
               </a:rPr>
+              <a:t>TF-IDF</a:t>
+            </a:r>
+          </a:p>
+          <a:p xmlns:a="http://schemas.openxmlformats.org/drawingml/2006/main">
+            <a:pPr algn="l">
+              <a:lnSpc>
+                <a:spcPct val="100000"/>
+              </a:lnSpc>
+              <a:buNone/>
+              <a:defRPr sz="2025" b="1">
+                <a:solidFill>
+                  <a:srgbClr val="051C2A"/>
+                </a:solidFill>
+                <a:latin typeface="Calibri"/>
+                <a:ea typeface="Calibri"/>
+                <a:cs typeface="Calibri"/>
+              </a:defRPr>
+            </a:pPr>
+            <a:r>
+              <a:rPr sz="2025" b="1">
+                <a:solidFill>
+                  <a:srgbClr val="051C2A"/>
+                </a:solidFill>
+                <a:latin typeface="Calibri"/>
+                <a:ea typeface="Calibri"/>
+                <a:cs typeface="Calibri"/>
+              </a:rPr>
               <a:t>Top-k</a:t>
-            </a:r>
-          </a:p>
-          <a:p xmlns:a="http://schemas.openxmlformats.org/drawingml/2006/main">
-            <a:pPr algn="l">
-              <a:lnSpc>
-                <a:spcPct val="100000"/>
-              </a:lnSpc>
-              <a:buNone/>
-              <a:defRPr sz="2025" b="1">
-                <a:solidFill>
-                  <a:srgbClr val="051C2A"/>
-                </a:solidFill>
-                <a:latin typeface="Calibri"/>
-                <a:ea typeface="Calibri"/>
-                <a:cs typeface="Calibri"/>
-              </a:defRPr>
-            </a:pPr>
-            <a:r>
-              <a:rPr sz="2025" b="1">
-                <a:solidFill>
-                  <a:srgbClr val="051C2A"/>
-                </a:solidFill>
-                <a:latin typeface="Calibri"/>
-                <a:ea typeface="Calibri"/>
-                <a:cs typeface="Calibri"/>
-              </a:rPr>
-              <a:t>context</a:t>
             </a:r>
           </a:p>
         </p:txBody>
@@ -5052,7 +5042,7 @@
                 <a:ea typeface="Calibri"/>
                 <a:cs typeface="Calibri"/>
               </a:rPr>
-              <a:t>SELECT</a:t>
+              <a:t>SELECT 2</a:t>
             </a:r>
           </a:p>
         </p:txBody>
@@ -5211,7 +5201,7 @@
                 <a:ea typeface="Calibri"/>
                 <a:cs typeface="Calibri"/>
               </a:rPr>
-              <a:t>Grounded</a:t>
+              <a:t>RAG</a:t>
             </a:r>
           </a:p>
           <a:p xmlns:a="http://schemas.openxmlformats.org/drawingml/2006/main">
@@ -5300,14 +5290,14 @@
                 <a:ea typeface="Calibri"/>
                 <a:cs typeface="Calibri"/>
               </a:rPr>
-              <a:t>GENERATE</a:t>
+              <a:t>CITE</a:t>
             </a:r>
           </a:p>
         </p:txBody>
       </p:sp>
       <p:cxnSp>
         <p:nvCxnSpPr>
-          <p:cNvPr id="55" name=""/>
+          <p:cNvPr id="107" name=""/>
           <p:cNvCxnSpPr>
             <a:stCxn xmlns:a="http://schemas.openxmlformats.org/drawingml/2006/main" id="3" idx="3"/>
             <a:endCxn xmlns:a="http://schemas.openxmlformats.org/drawingml/2006/main" id="7" idx="1"/>
@@ -5333,7 +5323,7 @@
       </p:cxnSp>
       <p:cxnSp>
         <p:nvCxnSpPr>
-          <p:cNvPr id="56" name=""/>
+          <p:cNvPr id="108" name=""/>
           <p:cNvCxnSpPr>
             <a:stCxn xmlns:a="http://schemas.openxmlformats.org/drawingml/2006/main" id="7" idx="3"/>
             <a:endCxn xmlns:a="http://schemas.openxmlformats.org/drawingml/2006/main" id="11" idx="1"/>
@@ -5359,7 +5349,7 @@
       </p:cxnSp>
       <p:cxnSp>
         <p:nvCxnSpPr>
-          <p:cNvPr id="57" name=""/>
+          <p:cNvPr id="109" name=""/>
           <p:cNvCxnSpPr>
             <a:stCxn xmlns:a="http://schemas.openxmlformats.org/drawingml/2006/main" id="11" idx="3"/>
             <a:endCxn xmlns:a="http://schemas.openxmlformats.org/drawingml/2006/main" id="15" idx="1"/>
@@ -5385,7 +5375,7 @@
       </p:cxnSp>
       <p:cxnSp>
         <p:nvCxnSpPr>
-          <p:cNvPr id="58" name=""/>
+          <p:cNvPr id="110" name=""/>
           <p:cNvCxnSpPr>
             <a:stCxn xmlns:a="http://schemas.openxmlformats.org/drawingml/2006/main" id="15" idx="3"/>
             <a:endCxn xmlns:a="http://schemas.openxmlformats.org/drawingml/2006/main" id="19" idx="1"/>
@@ -5439,7 +5429,7 @@
         </p:spPr>
         <p:txBody>
           <a:bodyPr xmlns:a="http://schemas.openxmlformats.org/drawingml/2006/main" wrap="square" lIns="0" tIns="0" rIns="0" bIns="0" anchor="ctr">
-            <a:normAutofit fontScale="100000"/>
+            <a:normAutofit fontScale="95131"/>
           </a:bodyPr>
           <a:lstStyle xmlns:a="http://schemas.openxmlformats.org/drawingml/2006/main"/>
           <a:p xmlns:a="http://schemas.openxmlformats.org/drawingml/2006/main">
@@ -5466,7 +5456,7 @@
                 <a:ea typeface="Calibri"/>
                 <a:cs typeface="Calibri"/>
               </a:rPr>
-              <a:t>Only stage 05 requires an LLM. Stages 01–04 are deterministic application logic.</a:t>
+              <a:t>No context and full context are references; naive RAG selects evidence before generation.</a:t>
             </a:r>
           </a:p>
         </p:txBody>
@@ -5656,7 +5646,7 @@
                 <a:ea typeface="Calibri"/>
                 <a:cs typeface="Calibri"/>
               </a:rPr>
-              <a:t>ARCHITECTURE</a:t>
+              <a:t>PATHS</a:t>
             </a:r>
           </a:p>
         </p:txBody>
@@ -13685,7 +13675,7 @@
       </p:sp>
       <p:cxnSp>
         <p:nvCxnSpPr>
-          <p:cNvPr id="44" name=""/>
+          <p:cNvPr id="100" name=""/>
           <p:cNvCxnSpPr>
             <a:stCxn xmlns:a="http://schemas.openxmlformats.org/drawingml/2006/main" id="5" idx="3"/>
             <a:endCxn xmlns:a="http://schemas.openxmlformats.org/drawingml/2006/main" id="6" idx="1"/>
@@ -13967,7 +13957,7 @@
       </p:sp>
       <p:cxnSp>
         <p:nvCxnSpPr>
-          <p:cNvPr id="50" name=""/>
+          <p:cNvPr id="106" name=""/>
           <p:cNvCxnSpPr>
             <a:stCxn xmlns:a="http://schemas.openxmlformats.org/drawingml/2006/main" id="11" idx="3"/>
             <a:endCxn xmlns:a="http://schemas.openxmlformats.org/drawingml/2006/main" id="12" idx="1"/>
@@ -14249,7 +14239,7 @@
       </p:sp>
       <p:cxnSp>
         <p:nvCxnSpPr>
-          <p:cNvPr id="56" name=""/>
+          <p:cNvPr id="112" name=""/>
           <p:cNvCxnSpPr>
             <a:stCxn xmlns:a="http://schemas.openxmlformats.org/drawingml/2006/main" id="17" idx="3"/>
             <a:endCxn xmlns:a="http://schemas.openxmlformats.org/drawingml/2006/main" id="18" idx="1"/>
@@ -14531,7 +14521,7 @@
       </p:sp>
       <p:cxnSp>
         <p:nvCxnSpPr>
-          <p:cNvPr id="62" name=""/>
+          <p:cNvPr id="118" name=""/>
           <p:cNvCxnSpPr>
             <a:stCxn xmlns:a="http://schemas.openxmlformats.org/drawingml/2006/main" id="23" idx="3"/>
             <a:endCxn xmlns:a="http://schemas.openxmlformats.org/drawingml/2006/main" id="24" idx="1"/>

</xml_diff>